<commit_message>
chore(examples): regenerate the committee-paper PPTX under Voice
Re-author the four-page Quick Generate example so titles and body match
Harbour Professional announcement copy, not Style method slogans.

Co-authored-by: Charliech <charleschtsoi@gmail.com>
</commit_message>
<xml_diff>
--- a/examples/ai_native_pptx_brief.pptx
+++ b/examples/ai_native_pptx_brief.pptx
@@ -112,7 +112,7 @@
 
 <file path=ppt/slideLayouts/slideLayout7.xml><?xml version="1.0" encoding="utf-8"?>
 <p:sldLayout xmlns:a="http://schemas.openxmlformats.org/drawingml/2006/main" xmlns:p="http://schemas.openxmlformats.org/presentationml/2006/main" type="blank" preserve="1">
-  <p:cSld name="hk_native_pptx_brief — Blank">
+  <p:cSld name="hk_committee_paper — Blank">
     <p:spTree>
       <p:nvGrpSpPr>
         <p:cNvPr id="1" name=""/>
@@ -202,7 +202,7 @@
 
 <file path=ppt/slideMasters/slideMaster1.xml><?xml version="1.0" encoding="utf-8"?>
 <p:sldMaster xmlns:a="http://schemas.openxmlformats.org/drawingml/2006/main" xmlns:p="http://schemas.openxmlformats.org/presentationml/2006/main" xmlns:r="http://schemas.openxmlformats.org/officeDocument/2006/relationships">
-  <p:cSld name="hk_native_pptx_brief — Master">
+  <p:cSld name="hk_committee_paper — Master">
     <p:bg>
       <p:bgRef idx="1001">
         <a:schemeClr val="bg1"/>
@@ -711,9 +711,9 @@
         <p:grpSpPr>
           <a:xfrm>
             <a:off x="1200150" y="1879600"/>
-            <a:ext cx="6291262" cy="1409700"/>
+            <a:ext cx="6477000" cy="1409700"/>
             <a:chOff x="1200150" y="1879600"/>
-            <a:chExt cx="6291262" cy="1409700"/>
+            <a:chExt cx="6477000" cy="1409700"/>
           </a:xfrm>
         </p:grpSpPr>
         <p:sp>
@@ -725,7 +725,7 @@
           <p:spPr>
             <a:xfrm>
               <a:off x="1200150" y="1879600"/>
-              <a:ext cx="6291262" cy="1409700"/>
+              <a:ext cx="6477000" cy="1409700"/>
             </a:xfrm>
             <a:prstGeom prst="rect">
               <a:avLst/>
@@ -755,29 +755,29 @@
                   <a:ea typeface="+mn-ea"/>
                   <a:cs typeface="+mn-cs"/>
                 </a:rPr>
-                <a:t>建議委員會採用</a:t>
-              </a:r>
-              <a:r>
-                <a:rPr lang="zh-HK" sz="3900" b="1" dirty="0">
-                  <a:solidFill>
-                    <a:srgbClr val="B8860B"/>
-                  </a:solidFill>
-                  <a:latin typeface="+mn-lt"/>
-                  <a:ea typeface="+mn-ea"/>
-                  <a:cs typeface="+mn-cs"/>
-                </a:rPr>
-                <a:t>可編輯 PPTX</a:t>
+                <a:t>建議委員會於下次會議前批准</a:t>
               </a:r>
               <a:br>
                 <a:rPr lang="zh-HK" sz="3900" b="1" dirty="0">
                   <a:solidFill>
+                    <a:srgbClr val="FFFFFF"/>
+                  </a:solidFill>
+                  <a:latin typeface="+mn-lt"/>
+                  <a:ea typeface="+mn-ea"/>
+                  <a:cs typeface="+mn-cs"/>
+                </a:rPr>
+              </a:br>
+              <a:r>
+                <a:rPr lang="zh-HK" sz="3900" b="1" dirty="0">
+                  <a:solidFill>
                     <a:srgbClr val="B8860B"/>
                   </a:solidFill>
                   <a:latin typeface="+mn-lt"/>
                   <a:ea typeface="+mn-ea"/>
                   <a:cs typeface="+mn-cs"/>
                 </a:rPr>
-              </a:br>
+                <a:t>可編輯 PPTX</a:t>
+              </a:r>
               <a:r>
                 <a:rPr lang="zh-HK" sz="3900" b="1" dirty="0">
                   <a:solidFill>
@@ -787,7 +787,7 @@
                   <a:ea typeface="+mn-ea"/>
                   <a:cs typeface="+mn-cs"/>
                 </a:rPr>
-                <a:t>作為本港文件的交付標準</a:t>
+                <a:t xml:space="preserve"> 為文件格式</a:t>
               </a:r>
             </a:p>
           </p:txBody>
@@ -802,9 +802,9 @@
         <p:grpSpPr>
           <a:xfrm>
             <a:off x="1210818" y="3771900"/>
-            <a:ext cx="6326979" cy="322707"/>
+            <a:ext cx="9416541" cy="322707"/>
             <a:chOff x="1210818" y="3771900"/>
-            <a:chExt cx="6326979" cy="322707"/>
+            <a:chExt cx="9416541" cy="322707"/>
           </a:xfrm>
         </p:grpSpPr>
         <p:sp>
@@ -816,7 +816,7 @@
           <p:spPr>
             <a:xfrm>
               <a:off x="1210818" y="3771900"/>
-              <a:ext cx="6326979" cy="322707"/>
+              <a:ext cx="9416541" cy="322707"/>
             </a:xfrm>
             <a:prstGeom prst="rect">
               <a:avLst/>
@@ -842,7 +842,7 @@
                   <a:ea typeface="+mj-ea"/>
                   <a:cs typeface="+mj-cs"/>
                 </a:rPr>
-                <a:t>Recommend the Committee adopt editable PPTX as the paper format</a:t>
+                <a:t>Recommend the Committee adopt editable PPTX as the paper format with effect from 28 October 2026</a:t>
               </a:r>
             </a:p>
           </p:txBody>
@@ -1236,10 +1236,10 @@
         </p:nvGrpSpPr>
         <p:grpSpPr>
           <a:xfrm>
-            <a:off x="755904" y="4914900"/>
-            <a:ext cx="2919984" cy="234696"/>
-            <a:chOff x="755904" y="4914900"/>
-            <a:chExt cx="2919984" cy="234696"/>
+            <a:off x="755904" y="4889500"/>
+            <a:ext cx="2145792" cy="463296"/>
+            <a:chOff x="755904" y="4889500"/>
+            <a:chExt cx="2145792" cy="463296"/>
           </a:xfrm>
         </p:grpSpPr>
         <p:sp>
@@ -1250,8 +1250,8 @@
           </p:nvSpPr>
           <p:spPr>
             <a:xfrm>
-              <a:off x="755904" y="4914900"/>
-              <a:ext cx="2919984" cy="234696"/>
+              <a:off x="755904" y="4889500"/>
+              <a:ext cx="2145792" cy="463296"/>
             </a:xfrm>
             <a:prstGeom prst="rect">
               <a:avLst/>
@@ -1267,7 +1267,11 @@
             </a:bodyPr>
             <a:lstStyle/>
             <a:p>
-              <a:pPr algn="l"/>
+              <a:pPr algn="l">
+                <a:lnSpc>
+                  <a:spcPts val="1800"/>
+                </a:lnSpc>
+              </a:pPr>
               <a:r>
                 <a:rPr lang="zh-HK" sz="1200" dirty="0">
                   <a:solidFill>
@@ -1277,7 +1281,28 @@
                   <a:ea typeface="+mn-ea"/>
                   <a:cs typeface="+mn-cs"/>
                 </a:rPr>
-                <a:t>會後須修訂的是文字與形狀，不是截圖。</a:t>
+                <a:t>秘書處須修訂的是文字與形狀，</a:t>
+              </a:r>
+              <a:br>
+                <a:rPr lang="zh-HK" sz="1200" dirty="0">
+                  <a:solidFill>
+                    <a:srgbClr val="B8860B"/>
+                  </a:solidFill>
+                  <a:latin typeface="+mn-lt"/>
+                  <a:ea typeface="+mn-ea"/>
+                  <a:cs typeface="+mn-cs"/>
+                </a:rPr>
+              </a:br>
+              <a:r>
+                <a:rPr lang="zh-HK" sz="1200" dirty="0">
+                  <a:solidFill>
+                    <a:srgbClr val="B8860B"/>
+                  </a:solidFill>
+                  <a:latin typeface="+mn-lt"/>
+                  <a:ea typeface="+mn-ea"/>
+                  <a:cs typeface="+mn-cs"/>
+                </a:rPr>
+                <a:t>截圖檔無法按委員意見改。</a:t>
               </a:r>
             </a:p>
           </p:txBody>
@@ -1430,9 +1455,9 @@
         <p:grpSpPr>
           <a:xfrm>
             <a:off x="899160" y="584200"/>
-            <a:ext cx="8954948" cy="957707"/>
+            <a:ext cx="8551088" cy="957707"/>
             <a:chOff x="899160" y="584200"/>
-            <a:chExt cx="8954948" cy="957707"/>
+            <a:chExt cx="8551088" cy="957707"/>
           </a:xfrm>
         </p:grpSpPr>
         <p:sp>
@@ -1444,7 +1469,7 @@
           <p:spPr>
             <a:xfrm>
               <a:off x="899160" y="584200"/>
-              <a:ext cx="8954948" cy="586740"/>
+              <a:ext cx="8551088" cy="586740"/>
             </a:xfrm>
             <a:prstGeom prst="rect">
               <a:avLst/>
@@ -1470,7 +1495,7 @@
                   <a:ea typeface="+mn-ea"/>
                   <a:cs typeface="+mn-cs"/>
                 </a:rPr>
-                <a:t>本範本四頁均為可點選的 DrawingML 形狀與文字</a:t>
+                <a:t>本檔四頁均為可點選的 DrawingML 文字與形狀</a:t>
               </a:r>
             </a:p>
           </p:txBody>
@@ -1484,7 +1509,7 @@
           <p:spPr>
             <a:xfrm>
               <a:off x="906018" y="1219200"/>
-              <a:ext cx="6308706" cy="322707"/>
+              <a:ext cx="6714479" cy="322707"/>
             </a:xfrm>
             <a:prstGeom prst="rect">
               <a:avLst/>
@@ -1510,7 +1535,7 @@
                   <a:ea typeface="+mj-ea"/>
                   <a:cs typeface="+mj-cs"/>
                 </a:rPr>
-                <a:t>Every page in this file is selectable DrawingML, not a picture of a slide</a:t>
+                <a:t>All four pages in this file are selectable DrawingML, not a picture of a slide</a:t>
               </a:r>
             </a:p>
           </p:txBody>
@@ -1518,27 +1543,82 @@
       </p:grpSp>
       <p:grpSp>
         <p:nvGrpSpPr>
-          <p:cNvPr id="9" name="proof-a"/>
+          <p:cNvPr id="7" name="proof-numeral"/>
           <p:cNvGrpSpPr/>
           <p:nvPr/>
         </p:nvGrpSpPr>
         <p:grpSpPr>
           <a:xfrm>
-            <a:off x="914400" y="2222500"/>
-            <a:ext cx="6199151" cy="712470"/>
-            <a:chOff x="914400" y="2222500"/>
-            <a:chExt cx="6199151" cy="712470"/>
+            <a:off x="895350" y="3111500"/>
+            <a:ext cx="2259330" cy="3162300"/>
+            <a:chOff x="895350" y="3111500"/>
+            <a:chExt cx="2259330" cy="3162300"/>
           </a:xfrm>
         </p:grpSpPr>
         <p:sp>
           <p:nvSpPr>
-            <p:cNvPr id="6" name="Rectangle 6"/>
+            <p:cNvPr id="6" name="TextBox 6"/>
+            <p:cNvSpPr txBox="1"/>
+            <p:nvPr/>
+          </p:nvSpPr>
+          <p:spPr>
+            <a:xfrm>
+              <a:off x="895350" y="3111500"/>
+              <a:ext cx="2259330" cy="3162300"/>
+            </a:xfrm>
+            <a:prstGeom prst="rect">
+              <a:avLst/>
+            </a:prstGeom>
+            <a:noFill/>
+            <a:ln>
+              <a:noFill/>
+            </a:ln>
+          </p:spPr>
+          <p:txBody>
+            <a:bodyPr wrap="none" lIns="0" tIns="0" rIns="0" bIns="0" anchor="t" anchorCtr="0">
+              <a:spAutoFit/>
+            </a:bodyPr>
+            <a:lstStyle/>
+            <a:p>
+              <a:pPr algn="l"/>
+              <a:r>
+                <a:rPr lang="zh-HK" sz="16500" b="1" dirty="0">
+                  <a:solidFill>
+                    <a:srgbClr val="123B5C"/>
+                  </a:solidFill>
+                  <a:latin typeface="+mn-lt"/>
+                  <a:ea typeface="+mn-ea"/>
+                  <a:cs typeface="+mn-cs"/>
+                </a:rPr>
+                <a:t>四</a:t>
+              </a:r>
+            </a:p>
+          </p:txBody>
+        </p:sp>
+      </p:grpSp>
+      <p:grpSp>
+        <p:nvGrpSpPr>
+          <p:cNvPr id="11" name="proof-a"/>
+          <p:cNvGrpSpPr/>
+          <p:nvPr/>
+        </p:nvGrpSpPr>
+        <p:grpSpPr>
+          <a:xfrm>
+            <a:off x="3810000" y="2374900"/>
+            <a:ext cx="6020689" cy="712470"/>
+            <a:chOff x="3810000" y="2374900"/>
+            <a:chExt cx="6020689" cy="712470"/>
+          </a:xfrm>
+        </p:grpSpPr>
+        <p:sp>
+          <p:nvSpPr>
+            <p:cNvPr id="8" name="Rectangle 8"/>
             <p:cNvSpPr/>
             <p:nvPr/>
           </p:nvSpPr>
           <p:spPr>
             <a:xfrm>
-              <a:off x="914400" y="2247900"/>
+              <a:off x="3810000" y="2400300"/>
               <a:ext cx="76200" cy="457200"/>
             </a:xfrm>
             <a:prstGeom prst="rect">
@@ -1554,13 +1634,13 @@
         </p:sp>
         <p:sp>
           <p:nvSpPr>
-            <p:cNvPr id="7" name="TextBox 7"/>
+            <p:cNvPr id="9" name="TextBox 9"/>
             <p:cNvSpPr txBox="1"/>
             <p:nvPr/>
           </p:nvSpPr>
           <p:spPr>
             <a:xfrm>
-              <a:off x="1210056" y="2222500"/>
+              <a:off x="4105656" y="2374900"/>
               <a:ext cx="5141697" cy="352044"/>
             </a:xfrm>
             <a:prstGeom prst="rect">
@@ -1594,14 +1674,14 @@
         </p:sp>
         <p:sp>
           <p:nvSpPr>
-            <p:cNvPr id="8" name="TextBox 8"/>
+            <p:cNvPr id="10" name="TextBox 10"/>
             <p:cNvSpPr txBox="1"/>
             <p:nvPr/>
           </p:nvSpPr>
           <p:spPr>
             <a:xfrm>
-              <a:off x="1211580" y="2641600"/>
-              <a:ext cx="5901971" cy="293370"/>
+              <a:off x="4107180" y="2794000"/>
+              <a:ext cx="5723509" cy="293370"/>
             </a:xfrm>
             <a:prstGeom prst="rect">
               <a:avLst/>
@@ -1627,7 +1707,7 @@
                   <a:ea typeface="+mj-ea"/>
                   <a:cs typeface="+mj-cs"/>
                 </a:rPr>
-                <a:t>Harbour navy and warm paper — not a Mainland government template</a:t>
+                <a:t>Harbour navy and warm paper, not a Mainland government template</a:t>
               </a:r>
             </a:p>
           </p:txBody>
@@ -1635,27 +1715,27 @@
       </p:grpSp>
       <p:grpSp>
         <p:nvGrpSpPr>
-          <p:cNvPr id="13" name="proof-b"/>
+          <p:cNvPr id="15" name="proof-b"/>
           <p:cNvGrpSpPr/>
           <p:nvPr/>
         </p:nvGrpSpPr>
         <p:grpSpPr>
           <a:xfrm>
-            <a:off x="914400" y="3556000"/>
+            <a:off x="3810000" y="3556000"/>
             <a:ext cx="6135658" cy="712470"/>
-            <a:chOff x="914400" y="3556000"/>
+            <a:chOff x="3810000" y="3556000"/>
             <a:chExt cx="6135658" cy="712470"/>
           </a:xfrm>
         </p:grpSpPr>
         <p:sp>
           <p:nvSpPr>
-            <p:cNvPr id="10" name="Rectangle 10"/>
+            <p:cNvPr id="12" name="Rectangle 12"/>
             <p:cNvSpPr/>
             <p:nvPr/>
           </p:nvSpPr>
           <p:spPr>
             <a:xfrm>
-              <a:off x="914400" y="3581400"/>
+              <a:off x="3810000" y="3581400"/>
               <a:ext cx="76200" cy="457200"/>
             </a:xfrm>
             <a:prstGeom prst="rect">
@@ -1671,13 +1751,13 @@
         </p:sp>
         <p:sp>
           <p:nvSpPr>
-            <p:cNvPr id="11" name="TextBox 11"/>
+            <p:cNvPr id="13" name="TextBox 13"/>
             <p:cNvSpPr txBox="1"/>
             <p:nvPr/>
           </p:nvSpPr>
           <p:spPr>
             <a:xfrm>
-              <a:off x="1210056" y="3556000"/>
+              <a:off x="4105656" y="3556000"/>
               <a:ext cx="5120446" cy="352044"/>
             </a:xfrm>
             <a:prstGeom prst="rect">
@@ -1704,20 +1784,20 @@
                   <a:ea typeface="+mn-ea"/>
                   <a:cs typeface="+mn-cs"/>
                 </a:rPr>
-                <a:t>語言標籤為 zh-HK，Office 採用香港繁體校對</a:t>
+                <a:t>檔案語言為 zh-HK，Office 採用香港繁體校對</a:t>
               </a:r>
             </a:p>
           </p:txBody>
         </p:sp>
         <p:sp>
           <p:nvSpPr>
-            <p:cNvPr id="12" name="TextBox 12"/>
+            <p:cNvPr id="14" name="TextBox 14"/>
             <p:cNvSpPr txBox="1"/>
             <p:nvPr/>
           </p:nvSpPr>
           <p:spPr>
             <a:xfrm>
-              <a:off x="1211580" y="3975100"/>
+              <a:off x="4107180" y="3975100"/>
               <a:ext cx="5838478" cy="293370"/>
             </a:xfrm>
             <a:prstGeom prst="rect">
@@ -1752,27 +1832,27 @@
       </p:grpSp>
       <p:grpSp>
         <p:nvGrpSpPr>
-          <p:cNvPr id="17" name="proof-c"/>
+          <p:cNvPr id="19" name="proof-c"/>
           <p:cNvGrpSpPr/>
           <p:nvPr/>
         </p:nvGrpSpPr>
         <p:grpSpPr>
           <a:xfrm>
-            <a:off x="914400" y="4889500"/>
-            <a:ext cx="7542877" cy="712470"/>
-            <a:chOff x="914400" y="4889500"/>
-            <a:chExt cx="7542877" cy="712470"/>
+            <a:off x="3810000" y="4737100"/>
+            <a:ext cx="6021189" cy="712470"/>
+            <a:chOff x="3810000" y="4737100"/>
+            <a:chExt cx="6021189" cy="712470"/>
           </a:xfrm>
         </p:grpSpPr>
         <p:sp>
           <p:nvSpPr>
-            <p:cNvPr id="14" name="Rectangle 14"/>
+            <p:cNvPr id="16" name="Rectangle 16"/>
             <p:cNvSpPr/>
             <p:nvPr/>
           </p:nvSpPr>
           <p:spPr>
             <a:xfrm>
-              <a:off x="914400" y="4914900"/>
+              <a:off x="3810000" y="4762500"/>
               <a:ext cx="76200" cy="457200"/>
             </a:xfrm>
             <a:prstGeom prst="rect">
@@ -1788,14 +1868,14 @@
         </p:sp>
         <p:sp>
           <p:nvSpPr>
-            <p:cNvPr id="15" name="TextBox 15"/>
+            <p:cNvPr id="17" name="TextBox 17"/>
             <p:cNvSpPr txBox="1"/>
             <p:nvPr/>
           </p:nvSpPr>
           <p:spPr>
             <a:xfrm>
-              <a:off x="1210056" y="4889500"/>
-              <a:ext cx="4725135" cy="352044"/>
+              <a:off x="4105656" y="4737100"/>
+              <a:ext cx="5209767" cy="352044"/>
             </a:xfrm>
             <a:prstGeom prst="rect">
               <a:avLst/>
@@ -1821,21 +1901,21 @@
                   <a:ea typeface="+mn-ea"/>
                   <a:cs typeface="+mn-cs"/>
                 </a:rPr>
-                <a:t>輸出可在 PowerPoint 續改，無需重做截圖</a:t>
+                <a:t>四頁輸出可在 PowerPoint 續改，無需重做截圖</a:t>
               </a:r>
             </a:p>
           </p:txBody>
         </p:sp>
         <p:sp>
           <p:nvSpPr>
-            <p:cNvPr id="16" name="TextBox 16"/>
+            <p:cNvPr id="18" name="TextBox 18"/>
             <p:cNvSpPr txBox="1"/>
             <p:nvPr/>
           </p:nvSpPr>
           <p:spPr>
             <a:xfrm>
-              <a:off x="1211580" y="5308600"/>
-              <a:ext cx="7245697" cy="293370"/>
+              <a:off x="4107180" y="5156200"/>
+              <a:ext cx="5724009" cy="293370"/>
             </a:xfrm>
             <a:prstGeom prst="rect">
               <a:avLst/>
@@ -1861,7 +1941,7 @@
                   <a:ea typeface="+mj-ea"/>
                   <a:cs typeface="+mj-cs"/>
                 </a:rPr>
-                <a:t>The export stays editable in PowerPoint and does not need to be rebuilt as a screenshot</a:t>
+                <a:t>All four pages stay editable in PowerPoint and do not need rebuilding</a:t>
               </a:r>
             </a:p>
           </p:txBody>
@@ -1869,7 +1949,7 @@
       </p:grpSp>
       <p:sp>
         <p:nvSpPr>
-          <p:cNvPr id="18" name="TextBox 18"/>
+          <p:cNvPr id="20" name="TextBox 20"/>
           <p:cNvSpPr txBox="1"/>
           <p:nvPr/>
         </p:nvSpPr>
@@ -2028,10 +2108,10 @@
         </p:nvGrpSpPr>
         <p:grpSpPr>
           <a:xfrm>
-            <a:off x="1203960" y="1917700"/>
-            <a:ext cx="7612380" cy="586740"/>
-            <a:chOff x="1203960" y="1917700"/>
-            <a:chExt cx="7612380" cy="586740"/>
+            <a:off x="1203960" y="1803400"/>
+            <a:ext cx="4459605" cy="1120140"/>
+            <a:chOff x="1203960" y="1803400"/>
+            <a:chExt cx="4459605" cy="1120140"/>
           </a:xfrm>
         </p:grpSpPr>
         <p:sp>
@@ -2042,8 +2122,8 @@
           </p:nvSpPr>
           <p:spPr>
             <a:xfrm>
-              <a:off x="1203960" y="1917700"/>
-              <a:ext cx="7612380" cy="586740"/>
+              <a:off x="1203960" y="1803400"/>
+              <a:ext cx="4459605" cy="1120140"/>
             </a:xfrm>
             <a:prstGeom prst="rect">
               <a:avLst/>
@@ -2059,7 +2139,11 @@
             </a:bodyPr>
             <a:lstStyle/>
             <a:p>
-              <a:pPr algn="l"/>
+              <a:pPr algn="l">
+                <a:lnSpc>
+                  <a:spcPts val="4200"/>
+                </a:lnSpc>
+              </a:pPr>
               <a:r>
                 <a:rPr lang="zh-HK" sz="3000" b="1" dirty="0">
                   <a:solidFill>
@@ -2069,7 +2153,28 @@
                   <a:ea typeface="+mn-ea"/>
                   <a:cs typeface="+mn-cs"/>
                 </a:rPr>
-                <a:t>請於下次會議前以本範本產出</a:t>
+                <a:t>請秘書處於下次會議前</a:t>
+              </a:r>
+              <a:br>
+                <a:rPr lang="zh-HK" sz="3000" b="1" dirty="0">
+                  <a:solidFill>
+                    <a:srgbClr val="FFFFFF"/>
+                  </a:solidFill>
+                  <a:latin typeface="+mn-lt"/>
+                  <a:ea typeface="+mn-ea"/>
+                  <a:cs typeface="+mn-cs"/>
+                </a:rPr>
+              </a:br>
+              <a:r>
+                <a:rPr lang="zh-HK" sz="3000" b="1" dirty="0">
+                  <a:solidFill>
+                    <a:srgbClr val="FFFFFF"/>
+                  </a:solidFill>
+                  <a:latin typeface="+mn-lt"/>
+                  <a:ea typeface="+mn-ea"/>
+                  <a:cs typeface="+mn-cs"/>
+                </a:rPr>
+                <a:t>按本範本產出</a:t>
               </a:r>
               <a:r>
                 <a:rPr lang="zh-HK" sz="3000" b="1" dirty="0">
@@ -2094,9 +2199,9 @@
         </p:nvGrpSpPr>
         <p:grpSpPr>
           <a:xfrm>
-            <a:off x="1210818" y="2781300"/>
+            <a:off x="1210818" y="3314700"/>
             <a:ext cx="7488715" cy="322707"/>
-            <a:chOff x="1210818" y="2781300"/>
+            <a:chOff x="1210818" y="3314700"/>
             <a:chExt cx="7488715" cy="322707"/>
           </a:xfrm>
         </p:grpSpPr>
@@ -2108,7 +2213,7 @@
           </p:nvSpPr>
           <p:spPr>
             <a:xfrm>
-              <a:off x="1210818" y="2781300"/>
+              <a:off x="1210818" y="3314700"/>
               <a:ext cx="7488715" cy="322707"/>
             </a:xfrm>
             <a:prstGeom prst="rect">
@@ -2149,9 +2254,9 @@
         </p:nvGrpSpPr>
         <p:grpSpPr>
           <a:xfrm>
-            <a:off x="1210056" y="3517900"/>
+            <a:off x="1210056" y="3937000"/>
             <a:ext cx="5618988" cy="1114044"/>
-            <a:chOff x="1210056" y="3517900"/>
+            <a:chOff x="1210056" y="3937000"/>
             <a:chExt cx="5618988" cy="1114044"/>
           </a:xfrm>
         </p:grpSpPr>
@@ -2163,7 +2268,7 @@
           </p:nvSpPr>
           <p:spPr>
             <a:xfrm>
-              <a:off x="1210056" y="3517900"/>
+              <a:off x="1210056" y="3937000"/>
               <a:ext cx="5618988" cy="1114044"/>
             </a:xfrm>
             <a:prstGeom prst="rect">
@@ -2294,9 +2399,9 @@
 </file>
 
 <file path=ppt/theme/theme1.xml><?xml version="1.0" encoding="utf-8"?>
-<a:theme xmlns:a="http://schemas.openxmlformats.org/drawingml/2006/main" name="hk_native_pptx_brief">
+<a:theme xmlns:a="http://schemas.openxmlformats.org/drawingml/2006/main" name="hk_committee_paper">
   <a:themeElements>
-    <a:clrScheme name="hk_native_pptx_brief">
+    <a:clrScheme name="hk_committee_paper">
       <a:dk1>
         <a:sysClr val="windowText" lastClr="000000"/>
       </a:dk1>
@@ -2334,7 +2439,7 @@
         <a:srgbClr val="800080"/>
       </a:folHlink>
     </a:clrScheme>
-    <a:fontScheme name="hk_native_pptx_brief">
+    <a:fontScheme name="hk_committee_paper">
       <a:majorFont>
         <a:latin typeface="Calibri"/>
         <a:ea typeface="Microsoft JhengHei"/>
@@ -2406,7 +2511,7 @@
         <a:font script="Geor" typeface="Sylfaen"/>
       </a:minorFont>
     </a:fontScheme>
-    <a:fmtScheme name="hk_native_pptx_brief">
+    <a:fmtScheme name="hk_committee_paper">
       <a:fillStyleLst>
         <a:solidFill>
           <a:schemeClr val="phClr"/>

</xml_diff>